<commit_message>
Put the live deploy URL on the closing slide
The service is up at vibe-cut.onrender.com, so the closing slide now shows
the address at a size that reads from the back of a room instead of the
"( 배포 후 입력 )" placeholder.

"배포 링크 공개와 접속 점검" was still listed under next steps; it is done,
so it is replaced with the reuse question the evidence slide raises.

The speaker note now carries the operational caveat: the free tier sleeps
after ~15 minutes idle and the first request afterwards takes ~50s, so the
link needs warming before the talk.

Co-Authored-By: Claude Opus 5 <noreply@anthropic.com>
</commit_message>
<xml_diff>
--- a/OnePickStory_demoday.pptx
+++ b/OnePickStory_demoday.pptx
@@ -1246,7 +1246,7 @@
 사진첩에 잠들어 있는 여행을 영상 한 편으로 남기는 것이 One Pick Story입니다.
 다음 단계로는 지인이 아닌 실사용자를 확보하고, 유료 전환을 실험해 보려고 합니다.
 감사합니다.
-※ 배포 주소를 넣은 뒤 이 줄을 수정할 것.</a:t>
+※ 발표 직전에 링크를 한 번 열어 서버를 깨워 둘 것 — 무료 플랜은 15분 유휴 후 잠들어 첫 접속이 50초 이상 걸린다.</a:t>
             </a:r>
             <a:endParaRPr lang="en-US" dirty="0"/>
           </a:p>
@@ -8171,7 +8171,7 @@
                 <a:ea typeface="Pretendard" pitchFamily="34" charset="-122"/>
                 <a:cs typeface="Pretendard" pitchFamily="34" charset="-120"/>
               </a:rPr>
-              <a:t>배포 링크 공개와 접속 점검</a:t>
+              <a:t>두 번째 영상까지 만드는지 관찰</a:t>
             </a:r>
             <a:endParaRPr lang="en-US" sz="1250" dirty="0"/>
           </a:p>
@@ -8423,12 +8423,12 @@
         </p:nvSpPr>
         <p:spPr>
           <a:xfrm>
-            <a:off x="914400" y="5349240"/>
-            <a:ext cx="10058400" cy="731520"/>
+            <a:off x="914400" y="5257800"/>
+            <a:ext cx="10058400" cy="868680"/>
           </a:xfrm>
           <a:prstGeom prst="roundRect">
             <a:avLst>
-              <a:gd name="adj" fmla="val 12500"/>
+              <a:gd name="adj" fmla="val 10526"/>
             </a:avLst>
           </a:prstGeom>
           <a:solidFill>
@@ -8445,24 +8445,63 @@
         </p:nvSpPr>
         <p:spPr>
           <a:xfrm>
-            <a:off x="1261872" y="5349240"/>
-            <a:ext cx="9326880" cy="731520"/>
-          </a:xfrm>
-          <a:prstGeom prst="rect">
-            <a:avLst/>
-          </a:prstGeom>
-          <a:noFill/>
-          <a:ln/>
-        </p:spPr>
-        <p:txBody>
-          <a:bodyPr wrap="square" lIns="0" tIns="0" rIns="0" bIns="0" rtlCol="0" anchor="ctr"/>
-          <a:lstStyle/>
-          <a:p>
-            <a:pPr indent="0" marL="0">
-              <a:buNone/>
-            </a:pPr>
-            <a:r>
-              <a:rPr lang="en-US" sz="1300" b="1" dirty="0">
+            <a:off x="1280160" y="5376672"/>
+            <a:ext cx="4023360" cy="256032"/>
+          </a:xfrm>
+          <a:prstGeom prst="rect">
+            <a:avLst/>
+          </a:prstGeom>
+          <a:noFill/>
+          <a:ln/>
+        </p:spPr>
+        <p:txBody>
+          <a:bodyPr wrap="square" lIns="0" tIns="0" rIns="0" bIns="0" rtlCol="0" anchor="ctr"/>
+          <a:lstStyle/>
+          <a:p>
+            <a:pPr indent="0" marL="0">
+              <a:buNone/>
+            </a:pPr>
+            <a:r>
+              <a:rPr lang="en-US" sz="1100" b="1" spc="100" kern="0" dirty="0">
+                <a:solidFill>
+                  <a:srgbClr val="726356"/>
+                </a:solidFill>
+                <a:latin typeface="Pretendard" pitchFamily="34" charset="0"/>
+                <a:ea typeface="Pretendard" pitchFamily="34" charset="-122"/>
+                <a:cs typeface="Pretendard" pitchFamily="34" charset="-120"/>
+              </a:rPr>
+              <a:t>지금 접속해 보실 수 있습니다</a:t>
+            </a:r>
+            <a:endParaRPr lang="en-US" sz="1100" dirty="0"/>
+          </a:p>
+        </p:txBody>
+      </p:sp>
+      <p:sp>
+        <p:nvSpPr>
+          <p:cNvPr id="21" name="Text 19"/>
+          <p:cNvSpPr txBox="1"/>
+          <p:nvPr/>
+        </p:nvSpPr>
+        <p:spPr>
+          <a:xfrm>
+            <a:off x="1280160" y="5614416"/>
+            <a:ext cx="6583680" cy="384048"/>
+          </a:xfrm>
+          <a:prstGeom prst="rect">
+            <a:avLst/>
+          </a:prstGeom>
+          <a:noFill/>
+          <a:ln/>
+        </p:spPr>
+        <p:txBody>
+          <a:bodyPr wrap="square" lIns="0" tIns="0" rIns="0" bIns="0" rtlCol="0" anchor="ctr"/>
+          <a:lstStyle/>
+          <a:p>
+            <a:pPr indent="0" marL="0">
+              <a:buNone/>
+            </a:pPr>
+            <a:r>
+              <a:rPr lang="en-US" sz="2100" b="1" dirty="0">
                 <a:solidFill>
                   <a:srgbClr val="B04517"/>
                 </a:solidFill>
@@ -8470,23 +8509,9 @@
                 <a:ea typeface="Pretendard" pitchFamily="34" charset="-122"/>
                 <a:cs typeface="Pretendard" pitchFamily="34" charset="-120"/>
               </a:rPr>
-              <a:t>배포 주소   </a:t>
-            </a:r>
-            <a:pPr indent="0" marL="0">
-              <a:buNone/>
-            </a:pPr>
-            <a:r>
-              <a:rPr lang="en-US" sz="1300" dirty="0">
-                <a:solidFill>
-                  <a:srgbClr val="726356"/>
-                </a:solidFill>
-                <a:latin typeface="Pretendard" pitchFamily="34" charset="0"/>
-                <a:ea typeface="Pretendard" pitchFamily="34" charset="-122"/>
-                <a:cs typeface="Pretendard" pitchFamily="34" charset="-120"/>
-              </a:rPr>
-              <a:t>( 배포 후 입력 )</a:t>
-            </a:r>
-            <a:endParaRPr lang="en-US" sz="1300" dirty="0"/>
+              <a:t>vibe-cut.onrender.com</a:t>
+            </a:r>
+            <a:endParaRPr lang="en-US" sz="2100" dirty="0"/>
           </a:p>
         </p:txBody>
       </p:sp>

</xml_diff>